<commit_message>
docs: update enterprise RAG plan presentation deck
</commit_message>
<xml_diff>
--- a/docs/enterprise-rag-plan-v2-deck.pptx
+++ b/docs/enterprise-rag-plan-v2-deck.pptx
@@ -4,6 +4,9 @@
   <p:sldMasterIdLst>
     <p:sldMasterId id="2147483648" r:id="rId1"/>
   </p:sldMasterIdLst>
+  <p:notesMasterIdLst>
+    <p:notesMasterId r:id="rId10"/>
+  </p:notesMasterIdLst>
   <p:sldIdLst>
     <p:sldId id="256" r:id="rId2"/>
     <p:sldId id="257" r:id="rId3"/>
@@ -14,11 +17,8 @@
     <p:sldId id="262" r:id="rId8"/>
     <p:sldId id="263" r:id="rId9"/>
   </p:sldIdLst>
-  <p:notesMasterIdLst>
-    <p:notesMasterId r:id="rId10"/>
-  </p:notesMasterIdLst>
-  <p:sldSz cx="12191695" cy="6858000"/>
-  <p:notesSz cx="6858000" cy="12191695"/>
+  <p:sldSz cx="12192000" cy="6858000"/>
+  <p:notesSz cx="6858000" cy="12192000"/>
   <p:defaultTextStyle>
     <a:lvl1pPr marL="0" algn="l" defTabSz="914400" rtl="0" eaLnBrk="1" latinLnBrk="0" hangingPunct="1">
       <a:defRPr sz="1800" kern="1200">
@@ -111,6 +111,11 @@
       </a:defRPr>
     </a:lvl9pPr>
   </p:defaultTextStyle>
+  <p:extLst>
+    <p:ext uri="{EFAFB233-063F-42B5-8137-9DF3F51BA10A}">
+      <p15:sldGuideLst xmlns:p15="http://schemas.microsoft.com/office/powerpoint/2012/main"/>
+    </p:ext>
+  </p:extLst>
 </p:presentation>
 </file>
 
@@ -136,240 +141,16 @@
           <a:chExt cx="0" cy="0"/>
         </a:xfrm>
       </p:grpSpPr>
-      <p:sp>
-        <p:nvSpPr>
-          <p:cNvPr id="2" name="Header Placeholder 1"/>
-          <p:cNvSpPr>
-            <a:spLocks noGrp="1"/>
-          </p:cNvSpPr>
-          <p:nvPr>
-            <p:ph type="hdr" sz="quarter"/>
-          </p:nvPr>
-        </p:nvSpPr>
-        <p:spPr>
-          <a:xfrm>
-            <a:off x="0" y="0"/>
-            <a:ext cx="2971800" cy="458788"/>
-          </a:xfrm>
-          <a:prstGeom prst="rect">
-            <a:avLst/>
-          </a:prstGeom>
-        </p:spPr>
-        <p:txBody>
-          <a:bodyPr vert="horz" lIns="91440" tIns="45720" rIns="91440" bIns="45720" rtlCol="0"/>
-          <a:lstStyle>
-            <a:lvl1pPr algn="l">
-              <a:defRPr sz="1200"/>
-            </a:lvl1pPr>
-          </a:lstStyle>
-          <a:p>
-            <a:endParaRPr lang="en-US"/>
-          </a:p>
-        </p:txBody>
-      </p:sp>
-      <p:sp>
-        <p:nvSpPr>
-          <p:cNvPr id="3" name="Date Placeholder 2"/>
-          <p:cNvSpPr>
-            <a:spLocks noGrp="1"/>
-          </p:cNvSpPr>
-          <p:nvPr>
-            <p:ph type="dt" idx="1"/>
-          </p:nvPr>
-        </p:nvSpPr>
-        <p:spPr>
-          <a:xfrm>
-            <a:off x="3884613" y="0"/>
-            <a:ext cx="2971800" cy="458788"/>
-          </a:xfrm>
-          <a:prstGeom prst="rect">
-            <a:avLst/>
-          </a:prstGeom>
-        </p:spPr>
-        <p:txBody>
-          <a:bodyPr vert="horz" lIns="91440" tIns="45720" rIns="91440" bIns="45720" rtlCol="0"/>
-          <a:lstStyle>
-            <a:lvl1pPr algn="r">
-              <a:defRPr sz="1200"/>
-            </a:lvl1pPr>
-          </a:lstStyle>
-          <a:p>
-            <a:fld id="{5282F153-3F37-0F45-9E97-73ACFA13230C}" type="datetimeFigureOut">
-              <a:rPr lang="en-US"/>
-              <a:t>7/23/19</a:t>
-            </a:fld>
-            <a:endParaRPr lang="en-US"/>
-          </a:p>
-        </p:txBody>
-      </p:sp>
-      <p:sp>
-        <p:nvSpPr>
-          <p:cNvPr id="4" name="Slide Image Placeholder 3"/>
-          <p:cNvSpPr>
-            <a:spLocks noGrp="1" noRot="1" noChangeAspect="1"/>
-          </p:cNvSpPr>
-          <p:nvPr>
-            <p:ph type="sldImg" idx="2"/>
-          </p:nvPr>
-        </p:nvSpPr>
-        <p:spPr>
-          <a:xfrm>
-            <a:off x="685800" y="1143000"/>
-            <a:ext cx="5486400" cy="3086100"/>
-          </a:xfrm>
-          <a:prstGeom prst="rect">
-            <a:avLst/>
-          </a:prstGeom>
-          <a:noFill/>
-          <a:ln w="12700">
-            <a:solidFill>
-              <a:prstClr val="black"/>
-            </a:solidFill>
-          </a:ln>
-        </p:spPr>
-        <p:txBody>
-          <a:bodyPr vert="horz" lIns="91440" tIns="45720" rIns="91440" bIns="45720" rtlCol="0" anchor="ctr"/>
-          <a:lstStyle/>
-          <a:p>
-            <a:endParaRPr lang="en-US"/>
-          </a:p>
-        </p:txBody>
-      </p:sp>
-      <p:sp>
-        <p:nvSpPr>
-          <p:cNvPr id="5" name="Notes Placeholder 4"/>
-          <p:cNvSpPr>
-            <a:spLocks noGrp="1"/>
-          </p:cNvSpPr>
-          <p:nvPr>
-            <p:ph type="body" sz="quarter" idx="3"/>
-          </p:nvPr>
-        </p:nvSpPr>
-        <p:spPr>
-          <a:xfrm>
-            <a:off x="685800" y="4400550"/>
-            <a:ext cx="5486400" cy="3600450"/>
-          </a:xfrm>
-          <a:prstGeom prst="rect">
-            <a:avLst/>
-          </a:prstGeom>
-        </p:spPr>
-        <p:txBody>
-          <a:bodyPr vert="horz" lIns="91440" tIns="45720" rIns="91440" bIns="45720" rtlCol="0"/>
-          <a:lstStyle/>
-          <a:p>
-            <a:pPr lvl="0"/>
-            <a:r>
-              <a:rPr lang="en-US"/>
-              <a:t>Click to edit Master text styles</a:t>
-            </a:r>
-          </a:p>
-          <a:p>
-            <a:pPr lvl="1"/>
-            <a:r>
-              <a:rPr lang="en-US"/>
-              <a:t>Second level</a:t>
-            </a:r>
-          </a:p>
-          <a:p>
-            <a:pPr lvl="2"/>
-            <a:r>
-              <a:rPr lang="en-US"/>
-              <a:t>Third level</a:t>
-            </a:r>
-          </a:p>
-          <a:p>
-            <a:pPr lvl="3"/>
-            <a:r>
-              <a:rPr lang="en-US"/>
-              <a:t>Fourth level</a:t>
-            </a:r>
-          </a:p>
-          <a:p>
-            <a:pPr lvl="4"/>
-            <a:r>
-              <a:rPr lang="en-US"/>
-              <a:t>Fifth level</a:t>
-            </a:r>
-          </a:p>
-        </p:txBody>
-      </p:sp>
-      <p:sp>
-        <p:nvSpPr>
-          <p:cNvPr id="6" name="Footer Placeholder 5"/>
-          <p:cNvSpPr>
-            <a:spLocks noGrp="1"/>
-          </p:cNvSpPr>
-          <p:nvPr>
-            <p:ph type="ftr" sz="quarter" idx="4"/>
-          </p:nvPr>
-        </p:nvSpPr>
-        <p:spPr>
-          <a:xfrm>
-            <a:off x="0" y="8685213"/>
-            <a:ext cx="2971800" cy="458787"/>
-          </a:xfrm>
-          <a:prstGeom prst="rect">
-            <a:avLst/>
-          </a:prstGeom>
-        </p:spPr>
-        <p:txBody>
-          <a:bodyPr vert="horz" lIns="91440" tIns="45720" rIns="91440" bIns="45720" rtlCol="0" anchor="b"/>
-          <a:lstStyle>
-            <a:lvl1pPr algn="l">
-              <a:defRPr sz="1200"/>
-            </a:lvl1pPr>
-          </a:lstStyle>
-          <a:p>
-            <a:endParaRPr lang="en-US"/>
-          </a:p>
-        </p:txBody>
-      </p:sp>
-      <p:sp>
-        <p:nvSpPr>
-          <p:cNvPr id="7" name="Slide Number Placeholder 6"/>
-          <p:cNvSpPr>
-            <a:spLocks noGrp="1"/>
-          </p:cNvSpPr>
-          <p:nvPr>
-            <p:ph type="sldNum" sz="quarter" idx="5"/>
-          </p:nvPr>
-        </p:nvSpPr>
-        <p:spPr>
-          <a:xfrm>
-            <a:off x="3884613" y="8685213"/>
-            <a:ext cx="2971800" cy="458787"/>
-          </a:xfrm>
-          <a:prstGeom prst="rect">
-            <a:avLst/>
-          </a:prstGeom>
-        </p:spPr>
-        <p:txBody>
-          <a:bodyPr vert="horz" lIns="91440" tIns="45720" rIns="91440" bIns="45720" rtlCol="0" anchor="b"/>
-          <a:lstStyle>
-            <a:lvl1pPr algn="r">
-              <a:defRPr sz="1200"/>
-            </a:lvl1pPr>
-          </a:lstStyle>
-          <a:p>
-            <a:fld id="{CE5E9CC1-C706-0F49-92D6-E571CC5EEA8F}" type="slidenum">
-              <a:rPr lang="en-US"/>
-              <a:t>‹#›</a:t>
-            </a:fld>
-            <a:endParaRPr lang="en-US"/>
-          </a:p>
-        </p:txBody>
-      </p:sp>
     </p:spTree>
     <p:extLst>
       <p:ext uri="{BB962C8B-B14F-4D97-AF65-F5344CB8AC3E}">
-        <p14:creationId xmlns:p14="http://schemas.microsoft.com/office/powerpoint/2010/main" val="1024086991"/>
+        <p14:creationId xmlns:p14="http://schemas.microsoft.com/office/powerpoint/2010/main" val="446847599"/>
       </p:ext>
     </p:extLst>
   </p:cSld>
   <p:clrMap bg1="lt1" tx1="dk1" bg2="lt2" tx2="dk2" accent1="accent1" accent2="accent2" accent3="accent3" accent4="accent4" accent5="accent5" accent6="accent6" hlink="hlink" folHlink="folHlink"/>
   <p:notesStyle>
-    <a:lvl1pPr marL="0" algn="l" defTabSz="914400" rtl="0" eaLnBrk="1" latinLnBrk="0" hangingPunct="1">
+    <a:lvl1pPr marL="0" algn="l" defTabSz="914400" rtl="0" eaLnBrk="1" latinLnBrk="1" hangingPunct="1">
       <a:defRPr sz="1200" kern="1200">
         <a:solidFill>
           <a:schemeClr val="tx1"/>
@@ -379,7 +160,7 @@
         <a:cs typeface="+mn-cs"/>
       </a:defRPr>
     </a:lvl1pPr>
-    <a:lvl2pPr marL="457200" algn="l" defTabSz="914400" rtl="0" eaLnBrk="1" latinLnBrk="0" hangingPunct="1">
+    <a:lvl2pPr marL="457200" algn="l" defTabSz="914400" rtl="0" eaLnBrk="1" latinLnBrk="1" hangingPunct="1">
       <a:defRPr sz="1200" kern="1200">
         <a:solidFill>
           <a:schemeClr val="tx1"/>
@@ -389,7 +170,7 @@
         <a:cs typeface="+mn-cs"/>
       </a:defRPr>
     </a:lvl2pPr>
-    <a:lvl3pPr marL="914400" algn="l" defTabSz="914400" rtl="0" eaLnBrk="1" latinLnBrk="0" hangingPunct="1">
+    <a:lvl3pPr marL="914400" algn="l" defTabSz="914400" rtl="0" eaLnBrk="1" latinLnBrk="1" hangingPunct="1">
       <a:defRPr sz="1200" kern="1200">
         <a:solidFill>
           <a:schemeClr val="tx1"/>
@@ -399,7 +180,7 @@
         <a:cs typeface="+mn-cs"/>
       </a:defRPr>
     </a:lvl3pPr>
-    <a:lvl4pPr marL="1371600" algn="l" defTabSz="914400" rtl="0" eaLnBrk="1" latinLnBrk="0" hangingPunct="1">
+    <a:lvl4pPr marL="1371600" algn="l" defTabSz="914400" rtl="0" eaLnBrk="1" latinLnBrk="1" hangingPunct="1">
       <a:defRPr sz="1200" kern="1200">
         <a:solidFill>
           <a:schemeClr val="tx1"/>
@@ -409,7 +190,7 @@
         <a:cs typeface="+mn-cs"/>
       </a:defRPr>
     </a:lvl4pPr>
-    <a:lvl5pPr marL="1828800" algn="l" defTabSz="914400" rtl="0" eaLnBrk="1" latinLnBrk="0" hangingPunct="1">
+    <a:lvl5pPr marL="1828800" algn="l" defTabSz="914400" rtl="0" eaLnBrk="1" latinLnBrk="1" hangingPunct="1">
       <a:defRPr sz="1200" kern="1200">
         <a:solidFill>
           <a:schemeClr val="tx1"/>
@@ -419,7 +200,7 @@
         <a:cs typeface="+mn-cs"/>
       </a:defRPr>
     </a:lvl5pPr>
-    <a:lvl6pPr marL="2286000" algn="l" defTabSz="914400" rtl="0" eaLnBrk="1" latinLnBrk="0" hangingPunct="1">
+    <a:lvl6pPr marL="2286000" algn="l" defTabSz="914400" rtl="0" eaLnBrk="1" latinLnBrk="1" hangingPunct="1">
       <a:defRPr sz="1200" kern="1200">
         <a:solidFill>
           <a:schemeClr val="tx1"/>
@@ -429,7 +210,7 @@
         <a:cs typeface="+mn-cs"/>
       </a:defRPr>
     </a:lvl6pPr>
-    <a:lvl7pPr marL="2743200" algn="l" defTabSz="914400" rtl="0" eaLnBrk="1" latinLnBrk="0" hangingPunct="1">
+    <a:lvl7pPr marL="2743200" algn="l" defTabSz="914400" rtl="0" eaLnBrk="1" latinLnBrk="1" hangingPunct="1">
       <a:defRPr sz="1200" kern="1200">
         <a:solidFill>
           <a:schemeClr val="tx1"/>
@@ -439,7 +220,7 @@
         <a:cs typeface="+mn-cs"/>
       </a:defRPr>
     </a:lvl7pPr>
-    <a:lvl8pPr marL="3200400" algn="l" defTabSz="914400" rtl="0" eaLnBrk="1" latinLnBrk="0" hangingPunct="1">
+    <a:lvl8pPr marL="3200400" algn="l" defTabSz="914400" rtl="0" eaLnBrk="1" latinLnBrk="1" hangingPunct="1">
       <a:defRPr sz="1200" kern="1200">
         <a:solidFill>
           <a:schemeClr val="tx1"/>
@@ -449,7 +230,7 @@
         <a:cs typeface="+mn-cs"/>
       </a:defRPr>
     </a:lvl8pPr>
-    <a:lvl9pPr marL="3657600" algn="l" defTabSz="914400" rtl="0" eaLnBrk="1" latinLnBrk="0" hangingPunct="1">
+    <a:lvl9pPr marL="3657600" algn="l" defTabSz="914400" rtl="0" eaLnBrk="1" latinLnBrk="1" hangingPunct="1">
       <a:defRPr sz="1200" kern="1200">
         <a:solidFill>
           <a:schemeClr val="tx1"/>
@@ -507,10 +288,6 @@
           <a:bodyPr/>
           <a:lstStyle/>
           <a:p>
-            <a:r>
-              <a:rPr lang="en-US" dirty="0"/>
-              <a:t/>
-            </a:r>
             <a:endParaRPr lang="en-US" dirty="0"/>
           </a:p>
         </p:txBody>
@@ -595,10 +372,6 @@
           <a:bodyPr/>
           <a:lstStyle/>
           <a:p>
-            <a:r>
-              <a:rPr lang="en-US" dirty="0"/>
-              <a:t/>
-            </a:r>
             <a:endParaRPr lang="en-US" dirty="0"/>
           </a:p>
         </p:txBody>
@@ -683,10 +456,6 @@
           <a:bodyPr/>
           <a:lstStyle/>
           <a:p>
-            <a:r>
-              <a:rPr lang="en-US" dirty="0"/>
-              <a:t/>
-            </a:r>
             <a:endParaRPr lang="en-US" dirty="0"/>
           </a:p>
         </p:txBody>
@@ -771,10 +540,6 @@
           <a:bodyPr/>
           <a:lstStyle/>
           <a:p>
-            <a:r>
-              <a:rPr lang="en-US" dirty="0"/>
-              <a:t/>
-            </a:r>
             <a:endParaRPr lang="en-US" dirty="0"/>
           </a:p>
         </p:txBody>
@@ -859,10 +624,6 @@
           <a:bodyPr/>
           <a:lstStyle/>
           <a:p>
-            <a:r>
-              <a:rPr lang="en-US" dirty="0"/>
-              <a:t/>
-            </a:r>
             <a:endParaRPr lang="en-US" dirty="0"/>
           </a:p>
         </p:txBody>
@@ -947,10 +708,6 @@
           <a:bodyPr/>
           <a:lstStyle/>
           <a:p>
-            <a:r>
-              <a:rPr lang="en-US" dirty="0"/>
-              <a:t/>
-            </a:r>
             <a:endParaRPr lang="en-US" dirty="0"/>
           </a:p>
         </p:txBody>
@@ -1035,10 +792,6 @@
           <a:bodyPr/>
           <a:lstStyle/>
           <a:p>
-            <a:r>
-              <a:rPr lang="en-US" dirty="0"/>
-              <a:t/>
-            </a:r>
             <a:endParaRPr lang="en-US" dirty="0"/>
           </a:p>
         </p:txBody>
@@ -1123,10 +876,6 @@
           <a:bodyPr/>
           <a:lstStyle/>
           <a:p>
-            <a:r>
-              <a:rPr lang="en-US" dirty="0"/>
-              <a:t/>
-            </a:r>
             <a:endParaRPr lang="en-US" dirty="0"/>
           </a:p>
         </p:txBody>
@@ -1200,6 +949,11 @@
 <file path=ppt/slideMasters/slideMaster1.xml><?xml version="1.0" encoding="utf-8"?>
 <p:sldMaster xmlns:a="http://schemas.openxmlformats.org/drawingml/2006/main" xmlns:r="http://schemas.openxmlformats.org/officeDocument/2006/relationships" xmlns:p="http://schemas.openxmlformats.org/presentationml/2006/main">
   <p:cSld>
+    <p:bg>
+      <p:bgRef idx="1001">
+        <a:schemeClr val="bg1"/>
+      </p:bgRef>
+    </p:bg>
     <p:spTree>
       <p:nvGrpSpPr>
         <p:cNvPr id="1" name=""/>
@@ -1493,14 +1247,14 @@
       </p:grpSpPr>
       <p:pic>
         <p:nvPicPr>
-          <p:cNvPr id="2" name="Image 0" descr="C:/Handyground/Workspace/git/flayAI/docs/_planbuild/logo.png">    </p:cNvPr>
+          <p:cNvPr id="2" name="Image 0" descr="C:/Handyground/Workspace/git/flayAI/docs/_planbuild/logo.png"/>
           <p:cNvPicPr>
             <a:picLocks noChangeAspect="1"/>
           </p:cNvPicPr>
           <p:nvPr/>
         </p:nvPicPr>
         <p:blipFill>
-          <a:blip r:embed="rId1"/>
+          <a:blip r:embed="rId3"/>
           <a:stretch>
             <a:fillRect/>
           </a:stretch>
@@ -1536,7 +1290,7 @@
           <a:bodyPr wrap="square" rtlCol="0" anchor="ctr"/>
           <a:lstStyle/>
           <a:p>
-            <a:pPr algn="l" indent="0" marL="0">
+            <a:pPr marL="0" indent="0" algn="l">
               <a:buNone/>
             </a:pPr>
             <a:r>
@@ -1575,7 +1329,7 @@
           <a:bodyPr wrap="square" rtlCol="0" anchor="ctr"/>
           <a:lstStyle/>
           <a:p>
-            <a:pPr algn="l" indent="0" marL="0">
+            <a:pPr marL="0" indent="0" algn="l">
               <a:buNone/>
             </a:pPr>
             <a:r>
@@ -1614,7 +1368,7 @@
           <a:bodyPr wrap="square" rtlCol="0" anchor="ctr"/>
           <a:lstStyle/>
           <a:p>
-            <a:pPr algn="l" indent="0" marL="0">
+            <a:pPr marL="0" indent="0" algn="l">
               <a:buNone/>
             </a:pPr>
             <a:r>
@@ -1651,6 +1405,13 @@
           </a:solidFill>
           <a:ln/>
         </p:spPr>
+        <p:txBody>
+          <a:bodyPr/>
+          <a:lstStyle/>
+          <a:p>
+            <a:endParaRPr lang="ko-KR" altLang="en-US"/>
+          </a:p>
+        </p:txBody>
       </p:sp>
       <p:sp>
         <p:nvSpPr>
@@ -1673,7 +1434,7 @@
           <a:bodyPr wrap="square" rtlCol="0" anchor="ctr"/>
           <a:lstStyle/>
           <a:p>
-            <a:pPr algn="l" indent="0" marL="0">
+            <a:pPr marL="0" indent="0" algn="l">
               <a:buNone/>
             </a:pPr>
             <a:r>
@@ -1687,9 +1448,6 @@
               </a:rPr>
               <a:t>사내 해커톤 (바이브코딩) · 1차 기획안 공모 제출</a:t>
             </a:r>
-            <a:pPr algn="l" indent="0" marL="0">
-              <a:buNone/>
-            </a:pPr>
             <a:r>
               <a:rPr lang="en-US" sz="1500" dirty="0">
                 <a:solidFill>
@@ -1751,7 +1509,7 @@
           <a:bodyPr wrap="square" rtlCol="0" anchor="ctr"/>
           <a:lstStyle/>
           <a:p>
-            <a:pPr algn="l" indent="0" marL="0">
+            <a:pPr marL="0" indent="0" algn="l">
               <a:buNone/>
             </a:pPr>
             <a:r>
@@ -1788,6 +1546,13 @@
           </a:solidFill>
           <a:ln/>
         </p:spPr>
+        <p:txBody>
+          <a:bodyPr/>
+          <a:lstStyle/>
+          <a:p>
+            <a:endParaRPr lang="ko-KR" altLang="en-US"/>
+          </a:p>
+        </p:txBody>
       </p:sp>
       <p:sp>
         <p:nvSpPr>
@@ -1810,7 +1575,7 @@
           <a:bodyPr wrap="square" rtlCol="0" anchor="ctr"/>
           <a:lstStyle/>
           <a:p>
-            <a:pPr algn="ctr" indent="0" marL="0">
+            <a:pPr marL="0" indent="0" algn="ctr">
               <a:buNone/>
             </a:pPr>
             <a:r>
@@ -1849,7 +1614,7 @@
           <a:bodyPr wrap="square" rtlCol="0" anchor="ctr"/>
           <a:lstStyle/>
           <a:p>
-            <a:pPr indent="0" marL="0">
+            <a:pPr marL="0" indent="0">
               <a:buNone/>
             </a:pPr>
             <a:r>
@@ -1888,7 +1653,7 @@
           <a:bodyPr wrap="square" rtlCol="0" anchor="ctr"/>
           <a:lstStyle/>
           <a:p>
-            <a:pPr indent="0" marL="0">
+            <a:pPr marL="0" indent="0">
               <a:buNone/>
             </a:pPr>
             <a:r>
@@ -1925,6 +1690,13 @@
           </a:solidFill>
           <a:ln/>
         </p:spPr>
+        <p:txBody>
+          <a:bodyPr/>
+          <a:lstStyle/>
+          <a:p>
+            <a:endParaRPr lang="ko-KR" altLang="en-US"/>
+          </a:p>
+        </p:txBody>
       </p:sp>
       <p:sp>
         <p:nvSpPr>
@@ -1947,7 +1719,7 @@
           <a:bodyPr wrap="square" rtlCol="0" anchor="ctr"/>
           <a:lstStyle/>
           <a:p>
-            <a:pPr algn="ctr" indent="0" marL="0">
+            <a:pPr marL="0" indent="0" algn="ctr">
               <a:buNone/>
             </a:pPr>
             <a:r>
@@ -1986,7 +1758,7 @@
           <a:bodyPr wrap="square" rtlCol="0" anchor="ctr"/>
           <a:lstStyle/>
           <a:p>
-            <a:pPr indent="0" marL="0">
+            <a:pPr marL="0" indent="0">
               <a:buNone/>
             </a:pPr>
             <a:r>
@@ -2025,7 +1797,7 @@
           <a:bodyPr wrap="square" rtlCol="0" anchor="ctr"/>
           <a:lstStyle/>
           <a:p>
-            <a:pPr indent="0" marL="0">
+            <a:pPr marL="0" indent="0">
               <a:buNone/>
             </a:pPr>
             <a:r>
@@ -2062,6 +1834,13 @@
           </a:solidFill>
           <a:ln/>
         </p:spPr>
+        <p:txBody>
+          <a:bodyPr/>
+          <a:lstStyle/>
+          <a:p>
+            <a:endParaRPr lang="ko-KR" altLang="en-US"/>
+          </a:p>
+        </p:txBody>
       </p:sp>
       <p:sp>
         <p:nvSpPr>
@@ -2084,7 +1863,7 @@
           <a:bodyPr wrap="square" rtlCol="0" anchor="ctr"/>
           <a:lstStyle/>
           <a:p>
-            <a:pPr algn="ctr" indent="0" marL="0">
+            <a:pPr marL="0" indent="0" algn="ctr">
               <a:buNone/>
             </a:pPr>
             <a:r>
@@ -2123,7 +1902,7 @@
           <a:bodyPr wrap="square" rtlCol="0" anchor="ctr"/>
           <a:lstStyle/>
           <a:p>
-            <a:pPr indent="0" marL="0">
+            <a:pPr marL="0" indent="0">
               <a:buNone/>
             </a:pPr>
             <a:r>
@@ -2162,7 +1941,7 @@
           <a:bodyPr wrap="square" rtlCol="0" anchor="ctr"/>
           <a:lstStyle/>
           <a:p>
-            <a:pPr indent="0" marL="0">
+            <a:pPr marL="0" indent="0">
               <a:buNone/>
             </a:pPr>
             <a:r>
@@ -2206,6 +1985,13 @@
             <a:prstDash val="solid"/>
           </a:ln>
         </p:spPr>
+        <p:txBody>
+          <a:bodyPr/>
+          <a:lstStyle/>
+          <a:p>
+            <a:endParaRPr lang="ko-KR" altLang="en-US"/>
+          </a:p>
+        </p:txBody>
       </p:sp>
       <p:sp>
         <p:nvSpPr>
@@ -2228,7 +2014,7 @@
           <a:bodyPr wrap="square" rtlCol="0" anchor="ctr"/>
           <a:lstStyle/>
           <a:p>
-            <a:pPr indent="0" marL="0">
+            <a:pPr marL="0" indent="0">
               <a:buNone/>
             </a:pPr>
             <a:r>
@@ -2242,9 +2028,6 @@
               </a:rPr>
               <a:t>사내 데이터는 외부 SaaS LLM 에 올리기 어렵습니다  →  </a:t>
             </a:r>
-            <a:pPr indent="0" marL="0">
-              <a:buNone/>
-            </a:pPr>
             <a:r>
               <a:rPr lang="en-US" sz="1600" b="1" dirty="0">
                 <a:solidFill>
@@ -2281,7 +2064,7 @@
           <a:bodyPr wrap="square" rtlCol="0" anchor="ctr"/>
           <a:lstStyle/>
           <a:p>
-            <a:pPr algn="l" indent="0" marL="0">
+            <a:pPr marL="0" indent="0" algn="l">
               <a:buNone/>
             </a:pPr>
             <a:r>
@@ -2320,7 +2103,7 @@
           <a:bodyPr wrap="square" rtlCol="0" anchor="ctr"/>
           <a:lstStyle/>
           <a:p>
-            <a:pPr algn="r" indent="0" marL="0">
+            <a:pPr marL="0" indent="0" algn="r">
               <a:buNone/>
             </a:pPr>
             <a:r>
@@ -2384,7 +2167,7 @@
           <a:bodyPr wrap="square" rtlCol="0" anchor="ctr"/>
           <a:lstStyle/>
           <a:p>
-            <a:pPr algn="l" indent="0" marL="0">
+            <a:pPr marL="0" indent="0" algn="l">
               <a:buNone/>
             </a:pPr>
             <a:r>
@@ -2529,7 +2312,7 @@
           <a:bodyPr wrap="square" rtlCol="0" anchor="t"/>
           <a:lstStyle/>
           <a:p>
-            <a:pPr indent="0" marL="0">
+            <a:pPr marL="0" indent="0">
               <a:lnSpc>
                 <a:spcPct val="120000"/>
               </a:lnSpc>
@@ -2546,30 +2329,48 @@
               </a:rPr>
               <a:t>사내 도구를 넘어  →  </a:t>
             </a:r>
-            <a:pPr indent="0" marL="0">
+            <a:r>
+              <a:rPr lang="en-US" sz="1500" b="1" dirty="0">
+                <a:solidFill>
+                  <a:srgbClr val="1F4E79"/>
+                </a:solidFill>
+                <a:latin typeface="맑은 고딕" pitchFamily="34" charset="0"/>
+                <a:ea typeface="맑은 고딕" pitchFamily="34" charset="-122"/>
+                <a:cs typeface="맑은 고딕" pitchFamily="34" charset="-120"/>
+              </a:rPr>
+              <a:t>온프레미스 그룹웨어 제품 </a:t>
+            </a:r>
+            <a:r>
+              <a:rPr lang="en-US" sz="1500" b="1" dirty="0" err="1">
+                <a:solidFill>
+                  <a:srgbClr val="1F4E79"/>
+                </a:solidFill>
+                <a:latin typeface="맑은 고딕" pitchFamily="34" charset="0"/>
+                <a:ea typeface="맑은 고딕" pitchFamily="34" charset="-122"/>
+                <a:cs typeface="맑은 고딕" pitchFamily="34" charset="-120"/>
+              </a:rPr>
+              <a:t>기능</a:t>
+            </a:r>
+            <a:r>
+              <a:rPr lang="en-US" sz="1500" dirty="0">
+                <a:solidFill>
+                  <a:srgbClr val="2E5A88"/>
+                </a:solidFill>
+                <a:latin typeface="맑은 고딕" pitchFamily="34" charset="0"/>
+                <a:ea typeface="맑은 고딕" pitchFamily="34" charset="-122"/>
+                <a:cs typeface="맑은 고딕" pitchFamily="34" charset="-120"/>
+              </a:rPr>
+              <a:t> </a:t>
+            </a:r>
+          </a:p>
+          <a:p>
+            <a:pPr marL="0" indent="0">
               <a:lnSpc>
                 <a:spcPct val="120000"/>
               </a:lnSpc>
               <a:buNone/>
             </a:pPr>
             <a:r>
-              <a:rPr lang="en-US" sz="1500" b="1" dirty="0">
-                <a:solidFill>
-                  <a:srgbClr val="1F4E79"/>
-                </a:solidFill>
-                <a:latin typeface="맑은 고딕" pitchFamily="34" charset="0"/>
-                <a:ea typeface="맑은 고딕" pitchFamily="34" charset="-122"/>
-                <a:cs typeface="맑은 고딕" pitchFamily="34" charset="-120"/>
-              </a:rPr>
-              <a:t>온프레미스 그룹웨어 제품 기능</a:t>
-            </a:r>
-            <a:pPr indent="0" marL="0">
-              <a:lnSpc>
-                <a:spcPct val="120000"/>
-              </a:lnSpc>
-              <a:buNone/>
-            </a:pPr>
-            <a:r>
               <a:rPr lang="en-US" sz="1500" dirty="0">
                 <a:solidFill>
                   <a:srgbClr val="2E5A88"/>
@@ -2578,7 +2379,7 @@
                 <a:ea typeface="맑은 고딕" pitchFamily="34" charset="-122"/>
                 <a:cs typeface="맑은 고딕" pitchFamily="34" charset="-120"/>
               </a:rPr>
-              <a:t>  (신규 매출 기회)</a:t>
+              <a:t>                             (신규 매출 기회)</a:t>
             </a:r>
             <a:endParaRPr lang="en-US" sz="1500" dirty="0"/>
           </a:p>
@@ -2610,6 +2411,13 @@
             <a:prstDash val="solid"/>
           </a:ln>
         </p:spPr>
+        <p:txBody>
+          <a:bodyPr/>
+          <a:lstStyle/>
+          <a:p>
+            <a:endParaRPr lang="ko-KR" altLang="en-US"/>
+          </a:p>
+        </p:txBody>
       </p:sp>
       <p:sp>
         <p:nvSpPr>
@@ -2632,7 +2440,7 @@
           <a:bodyPr wrap="square" rtlCol="0" anchor="ctr"/>
           <a:lstStyle/>
           <a:p>
-            <a:pPr algn="ctr" indent="0" marL="0">
+            <a:pPr marL="0" indent="0" algn="ctr">
               <a:buNone/>
             </a:pPr>
             <a:r>
@@ -2671,7 +2479,7 @@
           <a:bodyPr wrap="square" rtlCol="0" anchor="ctr"/>
           <a:lstStyle/>
           <a:p>
-            <a:pPr algn="ctr" indent="0" marL="0">
+            <a:pPr marL="0" indent="0" algn="ctr">
               <a:buNone/>
             </a:pPr>
             <a:r>
@@ -2715,6 +2523,13 @@
             <a:prstDash val="solid"/>
           </a:ln>
         </p:spPr>
+        <p:txBody>
+          <a:bodyPr/>
+          <a:lstStyle/>
+          <a:p>
+            <a:endParaRPr lang="ko-KR" altLang="en-US"/>
+          </a:p>
+        </p:txBody>
       </p:sp>
       <p:sp>
         <p:nvSpPr>
@@ -2737,7 +2552,7 @@
           <a:bodyPr wrap="square" rtlCol="0" anchor="ctr"/>
           <a:lstStyle/>
           <a:p>
-            <a:pPr algn="ctr" indent="0" marL="0">
+            <a:pPr marL="0" indent="0" algn="ctr">
               <a:buNone/>
             </a:pPr>
             <a:r>
@@ -2776,7 +2591,7 @@
           <a:bodyPr wrap="square" rtlCol="0" anchor="ctr"/>
           <a:lstStyle/>
           <a:p>
-            <a:pPr algn="ctr" indent="0" marL="0">
+            <a:pPr marL="0" indent="0" algn="ctr">
               <a:buNone/>
             </a:pPr>
             <a:r>
@@ -2820,6 +2635,13 @@
             <a:prstDash val="solid"/>
           </a:ln>
         </p:spPr>
+        <p:txBody>
+          <a:bodyPr/>
+          <a:lstStyle/>
+          <a:p>
+            <a:endParaRPr lang="ko-KR" altLang="en-US"/>
+          </a:p>
+        </p:txBody>
       </p:sp>
       <p:sp>
         <p:nvSpPr>
@@ -2842,7 +2664,7 @@
           <a:bodyPr wrap="square" rtlCol="0" anchor="ctr"/>
           <a:lstStyle/>
           <a:p>
-            <a:pPr algn="ctr" indent="0" marL="0">
+            <a:pPr marL="0" indent="0" algn="ctr">
               <a:buNone/>
             </a:pPr>
             <a:r>
@@ -2881,7 +2703,7 @@
           <a:bodyPr wrap="square" rtlCol="0" anchor="ctr"/>
           <a:lstStyle/>
           <a:p>
-            <a:pPr algn="ctr" indent="0" marL="0">
+            <a:pPr marL="0" indent="0" algn="ctr">
               <a:buNone/>
             </a:pPr>
             <a:r>
@@ -2925,6 +2747,13 @@
             <a:prstDash val="solid"/>
           </a:ln>
         </p:spPr>
+        <p:txBody>
+          <a:bodyPr/>
+          <a:lstStyle/>
+          <a:p>
+            <a:endParaRPr lang="ko-KR" altLang="en-US"/>
+          </a:p>
+        </p:txBody>
       </p:sp>
       <p:sp>
         <p:nvSpPr>
@@ -2947,7 +2776,7 @@
           <a:bodyPr wrap="square" rtlCol="0" anchor="ctr"/>
           <a:lstStyle/>
           <a:p>
-            <a:pPr algn="ctr" indent="0" marL="0">
+            <a:pPr marL="0" indent="0" algn="ctr">
               <a:buNone/>
             </a:pPr>
             <a:r>
@@ -2986,7 +2815,7 @@
           <a:bodyPr wrap="square" rtlCol="0" anchor="ctr"/>
           <a:lstStyle/>
           <a:p>
-            <a:pPr algn="ctr" indent="0" marL="0">
+            <a:pPr marL="0" indent="0" algn="ctr">
               <a:buNone/>
             </a:pPr>
             <a:r>
@@ -3025,7 +2854,7 @@
           <a:bodyPr wrap="square" rtlCol="0" anchor="ctr"/>
           <a:lstStyle/>
           <a:p>
-            <a:pPr algn="l" indent="0" marL="0">
+            <a:pPr marL="0" indent="0" algn="l">
               <a:buNone/>
             </a:pPr>
             <a:r>
@@ -3064,7 +2893,7 @@
           <a:bodyPr wrap="square" rtlCol="0" anchor="ctr"/>
           <a:lstStyle/>
           <a:p>
-            <a:pPr algn="r" indent="0" marL="0">
+            <a:pPr marL="0" indent="0" algn="r">
               <a:buNone/>
             </a:pPr>
             <a:r>
@@ -3128,7 +2957,7 @@
           <a:bodyPr wrap="square" rtlCol="0" anchor="ctr"/>
           <a:lstStyle/>
           <a:p>
-            <a:pPr algn="l" indent="0" marL="0">
+            <a:pPr marL="0" indent="0" algn="l">
               <a:buNone/>
             </a:pPr>
             <a:r>
@@ -3172,6 +3001,13 @@
             <a:prstDash val="solid"/>
           </a:ln>
         </p:spPr>
+        <p:txBody>
+          <a:bodyPr/>
+          <a:lstStyle/>
+          <a:p>
+            <a:endParaRPr lang="ko-KR" altLang="en-US"/>
+          </a:p>
+        </p:txBody>
       </p:sp>
       <p:sp>
         <p:nvSpPr>
@@ -3192,6 +3028,13 @@
           </a:solidFill>
           <a:ln/>
         </p:spPr>
+        <p:txBody>
+          <a:bodyPr/>
+          <a:lstStyle/>
+          <a:p>
+            <a:endParaRPr lang="ko-KR" altLang="en-US"/>
+          </a:p>
+        </p:txBody>
       </p:sp>
       <p:sp>
         <p:nvSpPr>
@@ -3214,7 +3057,7 @@
           <a:bodyPr wrap="square" rtlCol="0" anchor="ctr"/>
           <a:lstStyle/>
           <a:p>
-            <a:pPr algn="ctr" indent="0" marL="0">
+            <a:pPr marL="0" indent="0" algn="ctr">
               <a:buNone/>
             </a:pPr>
             <a:r>
@@ -3253,7 +3096,7 @@
           <a:bodyPr wrap="square" rtlCol="0" anchor="ctr"/>
           <a:lstStyle/>
           <a:p>
-            <a:pPr indent="0" marL="0">
+            <a:pPr marL="0" indent="0">
               <a:buNone/>
             </a:pPr>
             <a:r>
@@ -3292,7 +3135,7 @@
           <a:bodyPr wrap="square" rtlCol="0" anchor="t"/>
           <a:lstStyle/>
           <a:p>
-            <a:pPr indent="0" marL="0">
+            <a:pPr marL="0" indent="0">
               <a:lnSpc>
                 <a:spcPct val="115000"/>
               </a:lnSpc>
@@ -3339,6 +3182,13 @@
             <a:prstDash val="solid"/>
           </a:ln>
         </p:spPr>
+        <p:txBody>
+          <a:bodyPr/>
+          <a:lstStyle/>
+          <a:p>
+            <a:endParaRPr lang="ko-KR" altLang="en-US"/>
+          </a:p>
+        </p:txBody>
       </p:sp>
       <p:sp>
         <p:nvSpPr>
@@ -3359,6 +3209,13 @@
           </a:solidFill>
           <a:ln/>
         </p:spPr>
+        <p:txBody>
+          <a:bodyPr/>
+          <a:lstStyle/>
+          <a:p>
+            <a:endParaRPr lang="ko-KR" altLang="en-US"/>
+          </a:p>
+        </p:txBody>
       </p:sp>
       <p:sp>
         <p:nvSpPr>
@@ -3381,7 +3238,7 @@
           <a:bodyPr wrap="square" rtlCol="0" anchor="ctr"/>
           <a:lstStyle/>
           <a:p>
-            <a:pPr algn="ctr" indent="0" marL="0">
+            <a:pPr marL="0" indent="0" algn="ctr">
               <a:buNone/>
             </a:pPr>
             <a:r>
@@ -3420,7 +3277,7 @@
           <a:bodyPr wrap="square" rtlCol="0" anchor="ctr"/>
           <a:lstStyle/>
           <a:p>
-            <a:pPr indent="0" marL="0">
+            <a:pPr marL="0" indent="0">
               <a:buNone/>
             </a:pPr>
             <a:r>
@@ -3459,7 +3316,7 @@
           <a:bodyPr wrap="square" rtlCol="0" anchor="t"/>
           <a:lstStyle/>
           <a:p>
-            <a:pPr indent="0" marL="0">
+            <a:pPr marL="0" indent="0">
               <a:lnSpc>
                 <a:spcPct val="115000"/>
               </a:lnSpc>
@@ -3506,6 +3363,13 @@
             <a:prstDash val="solid"/>
           </a:ln>
         </p:spPr>
+        <p:txBody>
+          <a:bodyPr/>
+          <a:lstStyle/>
+          <a:p>
+            <a:endParaRPr lang="ko-KR" altLang="en-US"/>
+          </a:p>
+        </p:txBody>
       </p:sp>
       <p:sp>
         <p:nvSpPr>
@@ -3526,6 +3390,13 @@
           </a:solidFill>
           <a:ln/>
         </p:spPr>
+        <p:txBody>
+          <a:bodyPr/>
+          <a:lstStyle/>
+          <a:p>
+            <a:endParaRPr lang="ko-KR" altLang="en-US"/>
+          </a:p>
+        </p:txBody>
       </p:sp>
       <p:sp>
         <p:nvSpPr>
@@ -3548,7 +3419,7 @@
           <a:bodyPr wrap="square" rtlCol="0" anchor="ctr"/>
           <a:lstStyle/>
           <a:p>
-            <a:pPr algn="ctr" indent="0" marL="0">
+            <a:pPr marL="0" indent="0" algn="ctr">
               <a:buNone/>
             </a:pPr>
             <a:r>
@@ -3587,7 +3458,7 @@
           <a:bodyPr wrap="square" rtlCol="0" anchor="ctr"/>
           <a:lstStyle/>
           <a:p>
-            <a:pPr indent="0" marL="0">
+            <a:pPr marL="0" indent="0">
               <a:buNone/>
             </a:pPr>
             <a:r>
@@ -3614,7 +3485,7 @@
         <p:spPr>
           <a:xfrm>
             <a:off x="822960" y="4663440"/>
-            <a:ext cx="4892040" cy="822960"/>
+            <a:ext cx="4983480" cy="822960"/>
           </a:xfrm>
           <a:prstGeom prst="rect">
             <a:avLst/>
@@ -3626,7 +3497,7 @@
           <a:bodyPr wrap="square" rtlCol="0" anchor="t"/>
           <a:lstStyle/>
           <a:p>
-            <a:pPr indent="0" marL="0">
+            <a:pPr marL="0" indent="0">
               <a:lnSpc>
                 <a:spcPct val="115000"/>
               </a:lnSpc>
@@ -3673,6 +3544,13 @@
             <a:prstDash val="solid"/>
           </a:ln>
         </p:spPr>
+        <p:txBody>
+          <a:bodyPr/>
+          <a:lstStyle/>
+          <a:p>
+            <a:endParaRPr lang="ko-KR" altLang="en-US"/>
+          </a:p>
+        </p:txBody>
       </p:sp>
       <p:sp>
         <p:nvSpPr>
@@ -3693,6 +3571,13 @@
           </a:solidFill>
           <a:ln/>
         </p:spPr>
+        <p:txBody>
+          <a:bodyPr/>
+          <a:lstStyle/>
+          <a:p>
+            <a:endParaRPr lang="ko-KR" altLang="en-US"/>
+          </a:p>
+        </p:txBody>
       </p:sp>
       <p:sp>
         <p:nvSpPr>
@@ -3715,7 +3600,7 @@
           <a:bodyPr wrap="square" rtlCol="0" anchor="ctr"/>
           <a:lstStyle/>
           <a:p>
-            <a:pPr algn="ctr" indent="0" marL="0">
+            <a:pPr marL="0" indent="0" algn="ctr">
               <a:buNone/>
             </a:pPr>
             <a:r>
@@ -3754,7 +3639,7 @@
           <a:bodyPr wrap="square" rtlCol="0" anchor="ctr"/>
           <a:lstStyle/>
           <a:p>
-            <a:pPr indent="0" marL="0">
+            <a:pPr marL="0" indent="0">
               <a:buNone/>
             </a:pPr>
             <a:r>
@@ -3793,7 +3678,7 @@
           <a:bodyPr wrap="square" rtlCol="0" anchor="t"/>
           <a:lstStyle/>
           <a:p>
-            <a:pPr indent="0" marL="0">
+            <a:pPr marL="0" indent="0">
               <a:lnSpc>
                 <a:spcPct val="115000"/>
               </a:lnSpc>
@@ -3835,7 +3720,7 @@
           <a:bodyPr wrap="square" rtlCol="0" anchor="ctr"/>
           <a:lstStyle/>
           <a:p>
-            <a:pPr algn="l" indent="0" marL="0">
+            <a:pPr marL="0" indent="0" algn="l">
               <a:buNone/>
             </a:pPr>
             <a:r>
@@ -3874,7 +3759,7 @@
           <a:bodyPr wrap="square" rtlCol="0" anchor="ctr"/>
           <a:lstStyle/>
           <a:p>
-            <a:pPr algn="r" indent="0" marL="0">
+            <a:pPr marL="0" indent="0" algn="r">
               <a:buNone/>
             </a:pPr>
             <a:r>
@@ -3938,7 +3823,7 @@
           <a:bodyPr wrap="square" rtlCol="0" anchor="ctr"/>
           <a:lstStyle/>
           <a:p>
-            <a:pPr algn="l" indent="0" marL="0">
+            <a:pPr marL="0" indent="0" algn="l">
               <a:buNone/>
             </a:pPr>
             <a:r>
@@ -3993,7 +3878,29 @@
                 <a:ea typeface="맑은 고딕" pitchFamily="34" charset="-122"/>
                 <a:cs typeface="맑은 고딕" pitchFamily="34" charset="-120"/>
               </a:rPr>
-              <a:t>GPU 0원으로 시작 (기존 CPU 서버 1대)</a:t>
+              <a:t>GPU </a:t>
+            </a:r>
+            <a:r>
+              <a:rPr lang="ko-KR" altLang="en-US" sz="1600" dirty="0">
+                <a:solidFill>
+                  <a:srgbClr val="22262B"/>
+                </a:solidFill>
+                <a:latin typeface="맑은 고딕" pitchFamily="34" charset="0"/>
+                <a:ea typeface="맑은 고딕" pitchFamily="34" charset="-122"/>
+                <a:cs typeface="맑은 고딕" pitchFamily="34" charset="-120"/>
+              </a:rPr>
+              <a:t>없이</a:t>
+            </a:r>
+            <a:r>
+              <a:rPr lang="en-US" sz="1600" dirty="0">
+                <a:solidFill>
+                  <a:srgbClr val="22262B"/>
+                </a:solidFill>
+                <a:latin typeface="맑은 고딕" pitchFamily="34" charset="0"/>
+                <a:ea typeface="맑은 고딕" pitchFamily="34" charset="-122"/>
+                <a:cs typeface="맑은 고딕" pitchFamily="34" charset="-120"/>
+              </a:rPr>
+              <a:t> 시작 (기존 CPU 서버 1대)</a:t>
             </a:r>
             <a:endParaRPr lang="en-US" sz="1600" dirty="0"/>
           </a:p>
@@ -4085,14 +3992,14 @@
       </p:sp>
       <p:pic>
         <p:nvPicPr>
-          <p:cNvPr id="4" name="Image 0" descr="C:/Handyground/Workspace/git/flayAI/docs/_planbuild/sidepanel-mockup-v2.png">    </p:cNvPr>
+          <p:cNvPr id="4" name="Image 0" descr="C:/Handyground/Workspace/git/flayAI/docs/_planbuild/sidepanel-mockup-v2.png"/>
           <p:cNvPicPr>
             <a:picLocks noChangeAspect="1"/>
           </p:cNvPicPr>
           <p:nvPr/>
         </p:nvPicPr>
         <p:blipFill>
-          <a:blip r:embed="rId1"/>
+          <a:blip r:embed="rId3"/>
           <a:stretch>
             <a:fillRect/>
           </a:stretch>
@@ -4128,7 +4035,7 @@
           <a:bodyPr wrap="square" rtlCol="0" anchor="ctr"/>
           <a:lstStyle/>
           <a:p>
-            <a:pPr algn="ctr" indent="0" marL="0">
+            <a:pPr marL="0" indent="0" algn="ctr">
               <a:buNone/>
             </a:pPr>
             <a:r>
@@ -4167,7 +4074,7 @@
           <a:bodyPr wrap="square" rtlCol="0" anchor="ctr"/>
           <a:lstStyle/>
           <a:p>
-            <a:pPr algn="l" indent="0" marL="0">
+            <a:pPr marL="0" indent="0" algn="l">
               <a:buNone/>
             </a:pPr>
             <a:r>
@@ -4206,7 +4113,7 @@
           <a:bodyPr wrap="square" rtlCol="0" anchor="ctr"/>
           <a:lstStyle/>
           <a:p>
-            <a:pPr algn="r" indent="0" marL="0">
+            <a:pPr marL="0" indent="0" algn="r">
               <a:buNone/>
             </a:pPr>
             <a:r>
@@ -4270,7 +4177,7 @@
           <a:bodyPr wrap="square" rtlCol="0" anchor="ctr"/>
           <a:lstStyle/>
           <a:p>
-            <a:pPr algn="l" indent="0" marL="0">
+            <a:pPr marL="0" indent="0" algn="l">
               <a:buNone/>
             </a:pPr>
             <a:r>
@@ -4296,8 +4203,8 @@
         </p:nvSpPr>
         <p:spPr>
           <a:xfrm>
-            <a:off x="548640" y="1554480"/>
-            <a:ext cx="4572000" cy="3657600"/>
+            <a:off x="548639" y="1554480"/>
+            <a:ext cx="4787365" cy="3657600"/>
           </a:xfrm>
           <a:prstGeom prst="rect">
             <a:avLst/>
@@ -4417,14 +4324,14 @@
       </p:sp>
       <p:pic>
         <p:nvPicPr>
-          <p:cNvPr id="4" name="Image 0" descr="C:/Handyground/Workspace/git/flayAI/docs/_planbuild/sidepanel-mockup-v2-gpu.png">    </p:cNvPr>
+          <p:cNvPr id="4" name="Image 0" descr="C:/Handyground/Workspace/git/flayAI/docs/_planbuild/sidepanel-mockup-v2-gpu.png"/>
           <p:cNvPicPr>
             <a:picLocks noChangeAspect="1"/>
           </p:cNvPicPr>
           <p:nvPr/>
         </p:nvPicPr>
         <p:blipFill>
-          <a:blip r:embed="rId1"/>
+          <a:blip r:embed="rId3"/>
           <a:stretch>
             <a:fillRect/>
           </a:stretch>
@@ -4460,7 +4367,7 @@
           <a:bodyPr wrap="square" rtlCol="0" anchor="ctr"/>
           <a:lstStyle/>
           <a:p>
-            <a:pPr algn="ctr" indent="0" marL="0">
+            <a:pPr marL="0" indent="0" algn="ctr">
               <a:buNone/>
             </a:pPr>
             <a:r>
@@ -4499,7 +4406,7 @@
           <a:bodyPr wrap="square" rtlCol="0" anchor="ctr"/>
           <a:lstStyle/>
           <a:p>
-            <a:pPr algn="l" indent="0" marL="0">
+            <a:pPr marL="0" indent="0" algn="l">
               <a:buNone/>
             </a:pPr>
             <a:r>
@@ -4538,7 +4445,7 @@
           <a:bodyPr wrap="square" rtlCol="0" anchor="ctr"/>
           <a:lstStyle/>
           <a:p>
-            <a:pPr algn="r" indent="0" marL="0">
+            <a:pPr marL="0" indent="0" algn="r">
               <a:buNone/>
             </a:pPr>
             <a:r>
@@ -4602,7 +4509,7 @@
           <a:bodyPr wrap="square" rtlCol="0" anchor="ctr"/>
           <a:lstStyle/>
           <a:p>
-            <a:pPr algn="l" indent="0" marL="0">
+            <a:pPr marL="0" indent="0" algn="l">
               <a:buNone/>
             </a:pPr>
             <a:r>
@@ -4646,6 +4553,13 @@
             <a:prstDash val="solid"/>
           </a:ln>
         </p:spPr>
+        <p:txBody>
+          <a:bodyPr/>
+          <a:lstStyle/>
+          <a:p>
+            <a:endParaRPr lang="ko-KR" altLang="en-US"/>
+          </a:p>
+        </p:txBody>
       </p:sp>
       <p:sp>
         <p:nvSpPr>
@@ -4668,7 +4582,7 @@
           <a:bodyPr wrap="square" rtlCol="0" anchor="ctr"/>
           <a:lstStyle/>
           <a:p>
-            <a:pPr algn="ctr" indent="0" marL="0">
+            <a:pPr marL="0" indent="0" algn="ctr">
               <a:buNone/>
             </a:pPr>
             <a:r>
@@ -4707,7 +4621,7 @@
           <a:bodyPr wrap="square" rtlCol="0" anchor="t"/>
           <a:lstStyle/>
           <a:p>
-            <a:pPr algn="ctr" indent="0" marL="0">
+            <a:pPr marL="0" indent="0" algn="ctr">
               <a:lnSpc>
                 <a:spcPct val="105000"/>
               </a:lnSpc>
@@ -4754,6 +4668,13 @@
             <a:prstDash val="solid"/>
           </a:ln>
         </p:spPr>
+        <p:txBody>
+          <a:bodyPr/>
+          <a:lstStyle/>
+          <a:p>
+            <a:endParaRPr lang="ko-KR" altLang="en-US"/>
+          </a:p>
+        </p:txBody>
       </p:sp>
       <p:sp>
         <p:nvSpPr>
@@ -4776,7 +4697,7 @@
           <a:bodyPr wrap="square" rtlCol="0" anchor="ctr"/>
           <a:lstStyle/>
           <a:p>
-            <a:pPr algn="ctr" indent="0" marL="0">
+            <a:pPr marL="0" indent="0" algn="ctr">
               <a:buNone/>
             </a:pPr>
             <a:r>
@@ -4815,7 +4736,7 @@
           <a:bodyPr wrap="square" rtlCol="0" anchor="t"/>
           <a:lstStyle/>
           <a:p>
-            <a:pPr algn="ctr" indent="0" marL="0">
+            <a:pPr marL="0" indent="0" algn="ctr">
               <a:lnSpc>
                 <a:spcPct val="105000"/>
               </a:lnSpc>
@@ -4835,7 +4756,7 @@
             <a:endParaRPr lang="en-US" sz="1250" dirty="0"/>
           </a:p>
           <a:p>
-            <a:pPr algn="ctr" indent="0" marL="0">
+            <a:pPr marL="0" indent="0" algn="ctr">
               <a:lnSpc>
                 <a:spcPct val="105000"/>
               </a:lnSpc>
@@ -4882,6 +4803,13 @@
             <a:prstDash val="solid"/>
           </a:ln>
         </p:spPr>
+        <p:txBody>
+          <a:bodyPr/>
+          <a:lstStyle/>
+          <a:p>
+            <a:endParaRPr lang="ko-KR" altLang="en-US"/>
+          </a:p>
+        </p:txBody>
       </p:sp>
       <p:sp>
         <p:nvSpPr>
@@ -4904,7 +4832,7 @@
           <a:bodyPr wrap="square" rtlCol="0" anchor="ctr"/>
           <a:lstStyle/>
           <a:p>
-            <a:pPr algn="ctr" indent="0" marL="0">
+            <a:pPr marL="0" indent="0" algn="ctr">
               <a:buNone/>
             </a:pPr>
             <a:r>
@@ -4943,7 +4871,7 @@
           <a:bodyPr wrap="square" rtlCol="0" anchor="t"/>
           <a:lstStyle/>
           <a:p>
-            <a:pPr algn="ctr" indent="0" marL="0">
+            <a:pPr marL="0" indent="0" algn="ctr">
               <a:lnSpc>
                 <a:spcPct val="105000"/>
               </a:lnSpc>
@@ -4990,6 +4918,13 @@
             <a:prstDash val="solid"/>
           </a:ln>
         </p:spPr>
+        <p:txBody>
+          <a:bodyPr/>
+          <a:lstStyle/>
+          <a:p>
+            <a:endParaRPr lang="ko-KR" altLang="en-US"/>
+          </a:p>
+        </p:txBody>
       </p:sp>
       <p:sp>
         <p:nvSpPr>
@@ -5012,7 +4947,7 @@
           <a:bodyPr wrap="square" rtlCol="0" anchor="ctr"/>
           <a:lstStyle/>
           <a:p>
-            <a:pPr algn="ctr" indent="0" marL="0">
+            <a:pPr marL="0" indent="0" algn="ctr">
               <a:buNone/>
             </a:pPr>
             <a:r>
@@ -5051,7 +4986,7 @@
           <a:bodyPr wrap="square" rtlCol="0" anchor="t"/>
           <a:lstStyle/>
           <a:p>
-            <a:pPr algn="ctr" indent="0" marL="0">
+            <a:pPr marL="0" indent="0" algn="ctr">
               <a:lnSpc>
                 <a:spcPct val="105000"/>
               </a:lnSpc>
@@ -5071,7 +5006,7 @@
             <a:endParaRPr lang="en-US" sz="1250" dirty="0"/>
           </a:p>
           <a:p>
-            <a:pPr algn="ctr" indent="0" marL="0">
+            <a:pPr marL="0" indent="0" algn="ctr">
               <a:lnSpc>
                 <a:spcPct val="105000"/>
               </a:lnSpc>
@@ -5118,6 +5053,13 @@
             <a:prstDash val="solid"/>
           </a:ln>
         </p:spPr>
+        <p:txBody>
+          <a:bodyPr/>
+          <a:lstStyle/>
+          <a:p>
+            <a:endParaRPr lang="ko-KR" altLang="en-US"/>
+          </a:p>
+        </p:txBody>
       </p:sp>
       <p:sp>
         <p:nvSpPr>
@@ -5140,7 +5082,7 @@
           <a:bodyPr wrap="square" rtlCol="0" anchor="ctr"/>
           <a:lstStyle/>
           <a:p>
-            <a:pPr algn="ctr" indent="0" marL="0">
+            <a:pPr marL="0" indent="0" algn="ctr">
               <a:buNone/>
             </a:pPr>
             <a:r>
@@ -5179,7 +5121,7 @@
           <a:bodyPr wrap="square" rtlCol="0" anchor="t"/>
           <a:lstStyle/>
           <a:p>
-            <a:pPr algn="ctr" indent="0" marL="0">
+            <a:pPr marL="0" indent="0" algn="ctr">
               <a:lnSpc>
                 <a:spcPct val="105000"/>
               </a:lnSpc>
@@ -5199,7 +5141,7 @@
             <a:endParaRPr lang="en-US" sz="1250" dirty="0"/>
           </a:p>
           <a:p>
-            <a:pPr algn="ctr" indent="0" marL="0">
+            <a:pPr marL="0" indent="0" algn="ctr">
               <a:lnSpc>
                 <a:spcPct val="105000"/>
               </a:lnSpc>
@@ -5246,6 +5188,13 @@
             <a:prstDash val="solid"/>
           </a:ln>
         </p:spPr>
+        <p:txBody>
+          <a:bodyPr/>
+          <a:lstStyle/>
+          <a:p>
+            <a:endParaRPr lang="ko-KR" altLang="en-US"/>
+          </a:p>
+        </p:txBody>
       </p:sp>
       <p:sp>
         <p:nvSpPr>
@@ -5268,7 +5217,7 @@
           <a:bodyPr wrap="square" rtlCol="0" anchor="ctr"/>
           <a:lstStyle/>
           <a:p>
-            <a:pPr algn="ctr" indent="0" marL="0">
+            <a:pPr marL="0" indent="0" algn="ctr">
               <a:buNone/>
             </a:pPr>
             <a:r>
@@ -5307,7 +5256,7 @@
           <a:bodyPr wrap="square" rtlCol="0" anchor="t"/>
           <a:lstStyle/>
           <a:p>
-            <a:pPr algn="ctr" indent="0" marL="0">
+            <a:pPr marL="0" indent="0" algn="ctr">
               <a:lnSpc>
                 <a:spcPct val="105000"/>
               </a:lnSpc>
@@ -5349,7 +5298,7 @@
           <a:bodyPr wrap="square" rtlCol="0" anchor="ctr"/>
           <a:lstStyle/>
           <a:p>
-            <a:pPr algn="ctr" indent="0" marL="0">
+            <a:pPr marL="0" indent="0" algn="ctr">
               <a:buNone/>
             </a:pPr>
             <a:r>
@@ -5363,9 +5312,6 @@
               </a:rPr>
               <a:t>무GPU: P1~P2</a:t>
             </a:r>
-            <a:pPr algn="ctr" indent="0" marL="0">
-              <a:buNone/>
-            </a:pPr>
             <a:r>
               <a:rPr lang="en-US" sz="1500" dirty="0">
                 <a:solidFill>
@@ -5377,9 +5323,6 @@
               </a:rPr>
               <a:t>   ·   GPU: P3부터   ·   제품화: P4   ·   </a:t>
             </a:r>
-            <a:pPr algn="ctr" indent="0" marL="0">
-              <a:buNone/>
-            </a:pPr>
             <a:r>
               <a:rPr lang="en-US" sz="1500" b="1" dirty="0">
                 <a:solidFill>
@@ -5416,6 +5359,13 @@
           </a:solidFill>
           <a:ln/>
         </p:spPr>
+        <p:txBody>
+          <a:bodyPr/>
+          <a:lstStyle/>
+          <a:p>
+            <a:endParaRPr lang="ko-KR" altLang="en-US"/>
+          </a:p>
+        </p:txBody>
       </p:sp>
       <p:sp>
         <p:nvSpPr>
@@ -5438,7 +5388,7 @@
           <a:bodyPr wrap="square" rtlCol="0" anchor="ctr"/>
           <a:lstStyle/>
           <a:p>
-            <a:pPr indent="0" marL="0">
+            <a:pPr marL="0" indent="0">
               <a:buNone/>
             </a:pPr>
             <a:r>
@@ -5477,7 +5427,7 @@
           <a:bodyPr wrap="square" rtlCol="0" anchor="ctr"/>
           <a:lstStyle/>
           <a:p>
-            <a:pPr algn="l" indent="0" marL="0">
+            <a:pPr marL="0" indent="0" algn="l">
               <a:buNone/>
             </a:pPr>
             <a:r>
@@ -5516,7 +5466,7 @@
           <a:bodyPr wrap="square" rtlCol="0" anchor="ctr"/>
           <a:lstStyle/>
           <a:p>
-            <a:pPr algn="r" indent="0" marL="0">
+            <a:pPr marL="0" indent="0" algn="r">
               <a:buNone/>
             </a:pPr>
             <a:r>
@@ -5550,6 +5500,7 @@
         <a:solidFill>
           <a:srgbClr val="1F4E79"/>
         </a:solidFill>
+        <a:effectLst/>
       </p:bgPr>
     </p:bg>
     <p:spTree>
@@ -5587,7 +5538,7 @@
           <a:bodyPr wrap="square" rtlCol="0" anchor="t"/>
           <a:lstStyle/>
           <a:p>
-            <a:pPr indent="0" marL="0">
+            <a:pPr marL="0" indent="0">
               <a:lnSpc>
                 <a:spcPct val="110000"/>
               </a:lnSpc>
@@ -5607,7 +5558,7 @@
             <a:endParaRPr lang="en-US" sz="3400" dirty="0"/>
           </a:p>
           <a:p>
-            <a:pPr indent="0" marL="0">
+            <a:pPr marL="0" indent="0">
               <a:lnSpc>
                 <a:spcPct val="110000"/>
               </a:lnSpc>
@@ -5649,7 +5600,7 @@
           <a:bodyPr wrap="square" rtlCol="0" anchor="t"/>
           <a:lstStyle/>
           <a:p>
-            <a:pPr indent="0" marL="0">
+            <a:pPr marL="0" indent="0">
               <a:lnSpc>
                 <a:spcPct val="125000"/>
               </a:lnSpc>
@@ -5666,79 +5617,73 @@
               </a:rPr>
               <a:t>핵심 결정 사항 (검토 회의)</a:t>
             </a:r>
-            <a:pPr indent="0" marL="0">
+            <a:endParaRPr lang="en-US" sz="1600" dirty="0"/>
+          </a:p>
+          <a:p>
+            <a:pPr marL="0" indent="0">
               <a:lnSpc>
                 <a:spcPct val="125000"/>
               </a:lnSpc>
               <a:buNone/>
             </a:pPr>
+            <a:r>
+              <a:rPr lang="en-US" sz="1500" dirty="0">
+                <a:solidFill>
+                  <a:srgbClr val="FFFFFF"/>
+                </a:solidFill>
+                <a:latin typeface="맑은 고딕" pitchFamily="34" charset="0"/>
+                <a:ea typeface="맑은 고딕" pitchFamily="34" charset="-122"/>
+                <a:cs typeface="맑은 고딕" pitchFamily="34" charset="-120"/>
+              </a:rPr>
+              <a:t>· 게시판 연동 방식 · 공개/제한 판정 기준</a:t>
+            </a:r>
             <a:endParaRPr lang="en-US" sz="1600" dirty="0"/>
           </a:p>
           <a:p>
-            <a:pPr indent="0" marL="0">
+            <a:pPr marL="0" indent="0">
               <a:lnSpc>
                 <a:spcPct val="125000"/>
               </a:lnSpc>
               <a:buNone/>
             </a:pPr>
-            <a:r>
-              <a:rPr lang="en-US" sz="1500" dirty="0">
-                <a:solidFill>
-                  <a:srgbClr val="FFFFFF"/>
-                </a:solidFill>
-                <a:latin typeface="맑은 고딕" pitchFamily="34" charset="0"/>
-                <a:ea typeface="맑은 고딕" pitchFamily="34" charset="-122"/>
-                <a:cs typeface="맑은 고딕" pitchFamily="34" charset="-120"/>
-              </a:rPr>
-              <a:t>· 게시판 연동 방식 · 공개/제한 판정 기준</a:t>
-            </a:r>
             <a:endParaRPr lang="en-US" sz="1600" dirty="0"/>
           </a:p>
           <a:p>
-            <a:pPr indent="0" marL="0">
+            <a:pPr marL="0" indent="0">
               <a:lnSpc>
                 <a:spcPct val="125000"/>
               </a:lnSpc>
               <a:buNone/>
             </a:pPr>
+            <a:r>
+              <a:rPr lang="en-US" sz="1500" dirty="0">
+                <a:solidFill>
+                  <a:srgbClr val="FFFFFF"/>
+                </a:solidFill>
+                <a:latin typeface="맑은 고딕" pitchFamily="34" charset="0"/>
+                <a:ea typeface="맑은 고딕" pitchFamily="34" charset="-122"/>
+                <a:cs typeface="맑은 고딕" pitchFamily="34" charset="-120"/>
+              </a:rPr>
+              <a:t>· 제품화(그룹웨어 탑재) 시점 · 패키징</a:t>
+            </a:r>
             <a:endParaRPr lang="en-US" sz="1600" dirty="0"/>
           </a:p>
           <a:p>
-            <a:pPr indent="0" marL="0">
+            <a:pPr marL="0" indent="0">
               <a:lnSpc>
                 <a:spcPct val="125000"/>
               </a:lnSpc>
               <a:buNone/>
             </a:pPr>
-            <a:r>
-              <a:rPr lang="en-US" sz="1500" dirty="0">
-                <a:solidFill>
-                  <a:srgbClr val="FFFFFF"/>
-                </a:solidFill>
-                <a:latin typeface="맑은 고딕" pitchFamily="34" charset="0"/>
-                <a:ea typeface="맑은 고딕" pitchFamily="34" charset="-122"/>
-                <a:cs typeface="맑은 고딕" pitchFamily="34" charset="-120"/>
-              </a:rPr>
-              <a:t>· 제품화(그룹웨어 탑재) 시점 · 패키징</a:t>
-            </a:r>
             <a:endParaRPr lang="en-US" sz="1600" dirty="0"/>
           </a:p>
           <a:p>
-            <a:pPr indent="0" marL="0">
+            <a:pPr marL="0" indent="0">
               <a:lnSpc>
                 <a:spcPct val="125000"/>
               </a:lnSpc>
               <a:buNone/>
             </a:pPr>
-            <a:endParaRPr lang="en-US" sz="1600" dirty="0"/>
-          </a:p>
-          <a:p>
-            <a:pPr indent="0" marL="0">
-              <a:lnSpc>
-                <a:spcPct val="125000"/>
-              </a:lnSpc>
-              <a:buNone/>
-            </a:pPr>
             <a:r>
               <a:rPr lang="en-US" sz="1500" dirty="0">
                 <a:solidFill>
@@ -5775,7 +5720,7 @@
           <a:bodyPr wrap="square" rtlCol="0" anchor="ctr"/>
           <a:lstStyle/>
           <a:p>
-            <a:pPr indent="0" marL="0">
+            <a:pPr marL="0" indent="0">
               <a:buNone/>
             </a:pPr>
             <a:r>
@@ -6094,4 +6039,319 @@
     </a:ext>
   </a:extLst>
 </a:theme>
+</file>
+
+<file path=ppt/theme/theme2.xml><?xml version="1.0" encoding="utf-8"?>
+<a:theme xmlns:a="http://schemas.openxmlformats.org/drawingml/2006/main" name="Office 테마">
+  <a:themeElements>
+    <a:clrScheme name="Office">
+      <a:dk1>
+        <a:sysClr val="windowText" lastClr="000000"/>
+      </a:dk1>
+      <a:lt1>
+        <a:sysClr val="window" lastClr="FFFFFF"/>
+      </a:lt1>
+      <a:dk2>
+        <a:srgbClr val="0E2841"/>
+      </a:dk2>
+      <a:lt2>
+        <a:srgbClr val="E8E8E8"/>
+      </a:lt2>
+      <a:accent1>
+        <a:srgbClr val="156082"/>
+      </a:accent1>
+      <a:accent2>
+        <a:srgbClr val="E97132"/>
+      </a:accent2>
+      <a:accent3>
+        <a:srgbClr val="196B24"/>
+      </a:accent3>
+      <a:accent4>
+        <a:srgbClr val="0F9ED5"/>
+      </a:accent4>
+      <a:accent5>
+        <a:srgbClr val="A02B93"/>
+      </a:accent5>
+      <a:accent6>
+        <a:srgbClr val="4EA72E"/>
+      </a:accent6>
+      <a:hlink>
+        <a:srgbClr val="467886"/>
+      </a:hlink>
+      <a:folHlink>
+        <a:srgbClr val="96607D"/>
+      </a:folHlink>
+    </a:clrScheme>
+    <a:fontScheme name="Office">
+      <a:majorFont>
+        <a:latin typeface="맑은 고딕" panose="02110004020202020204"/>
+        <a:ea typeface=""/>
+        <a:cs typeface=""/>
+        <a:font script="Jpan" typeface="游ゴシック Light"/>
+        <a:font script="Hang" typeface="맑은 고딕"/>
+        <a:font script="Hans" typeface="等线 Light"/>
+        <a:font script="Hant" typeface="新細明體"/>
+        <a:font script="Arab" typeface="Times New Roman"/>
+        <a:font script="Hebr" typeface="Times New Roman"/>
+        <a:font script="Thai" typeface="Angsana New"/>
+        <a:font script="Ethi" typeface="Nyala"/>
+        <a:font script="Beng" typeface="Vrinda"/>
+        <a:font script="Gujr" typeface="Shruti"/>
+        <a:font script="Khmr" typeface="MoolBoran"/>
+        <a:font script="Knda" typeface="Tunga"/>
+        <a:font script="Guru" typeface="Raavi"/>
+        <a:font script="Cans" typeface="Euphemia"/>
+        <a:font script="Cher" typeface="Plantagenet Cherokee"/>
+        <a:font script="Yiii" typeface="Microsoft Yi Baiti"/>
+        <a:font script="Tibt" typeface="Microsoft Himalaya"/>
+        <a:font script="Thaa" typeface="MV Boli"/>
+        <a:font script="Deva" typeface="Mangal"/>
+        <a:font script="Telu" typeface="Gautami"/>
+        <a:font script="Taml" typeface="Latha"/>
+        <a:font script="Syrc" typeface="Estrangelo Edessa"/>
+        <a:font script="Orya" typeface="Kalinga"/>
+        <a:font script="Mlym" typeface="Kartika"/>
+        <a:font script="Laoo" typeface="DokChampa"/>
+        <a:font script="Sinh" typeface="Iskoola Pota"/>
+        <a:font script="Mong" typeface="Mongolian Baiti"/>
+        <a:font script="Viet" typeface="Times New Roman"/>
+        <a:font script="Uigh" typeface="Microsoft Uighur"/>
+        <a:font script="Geor" typeface="Sylfaen"/>
+        <a:font script="Armn" typeface="Arial"/>
+        <a:font script="Bugi" typeface="Leelawadee UI"/>
+        <a:font script="Bopo" typeface="Microsoft JhengHei"/>
+        <a:font script="Java" typeface="Javanese Text"/>
+        <a:font script="Lisu" typeface="Segoe UI"/>
+        <a:font script="Mymr" typeface="Myanmar Text"/>
+        <a:font script="Nkoo" typeface="Ebrima"/>
+        <a:font script="Olck" typeface="Nirmala UI"/>
+        <a:font script="Osma" typeface="Ebrima"/>
+        <a:font script="Phag" typeface="Phagspa"/>
+        <a:font script="Syrn" typeface="Estrangelo Edessa"/>
+        <a:font script="Syrj" typeface="Estrangelo Edessa"/>
+        <a:font script="Syre" typeface="Estrangelo Edessa"/>
+        <a:font script="Sora" typeface="Nirmala UI"/>
+        <a:font script="Tale" typeface="Microsoft Tai Le"/>
+        <a:font script="Talu" typeface="Microsoft New Tai Lue"/>
+        <a:font script="Tfng" typeface="Ebrima"/>
+      </a:majorFont>
+      <a:minorFont>
+        <a:latin typeface="맑은 고딕" panose="02110004020202020204"/>
+        <a:ea typeface=""/>
+        <a:cs typeface=""/>
+        <a:font script="Jpan" typeface="游ゴシック"/>
+        <a:font script="Hang" typeface="맑은 고딕"/>
+        <a:font script="Hans" typeface="等线"/>
+        <a:font script="Hant" typeface="新細明體"/>
+        <a:font script="Arab" typeface="Arial"/>
+        <a:font script="Hebr" typeface="Arial"/>
+        <a:font script="Thai" typeface="Cordia New"/>
+        <a:font script="Ethi" typeface="Nyala"/>
+        <a:font script="Beng" typeface="Vrinda"/>
+        <a:font script="Gujr" typeface="Shruti"/>
+        <a:font script="Khmr" typeface="DaunPenh"/>
+        <a:font script="Knda" typeface="Tunga"/>
+        <a:font script="Guru" typeface="Raavi"/>
+        <a:font script="Cans" typeface="Euphemia"/>
+        <a:font script="Cher" typeface="Plantagenet Cherokee"/>
+        <a:font script="Yiii" typeface="Microsoft Yi Baiti"/>
+        <a:font script="Tibt" typeface="Microsoft Himalaya"/>
+        <a:font script="Thaa" typeface="MV Boli"/>
+        <a:font script="Deva" typeface="Mangal"/>
+        <a:font script="Telu" typeface="Gautami"/>
+        <a:font script="Taml" typeface="Latha"/>
+        <a:font script="Syrc" typeface="Estrangelo Edessa"/>
+        <a:font script="Orya" typeface="Kalinga"/>
+        <a:font script="Mlym" typeface="Kartika"/>
+        <a:font script="Laoo" typeface="DokChampa"/>
+        <a:font script="Sinh" typeface="Iskoola Pota"/>
+        <a:font script="Mong" typeface="Mongolian Baiti"/>
+        <a:font script="Viet" typeface="Arial"/>
+        <a:font script="Uigh" typeface="Microsoft Uighur"/>
+        <a:font script="Geor" typeface="Sylfaen"/>
+        <a:font script="Armn" typeface="Arial"/>
+        <a:font script="Bugi" typeface="Leelawadee UI"/>
+        <a:font script="Bopo" typeface="Microsoft JhengHei"/>
+        <a:font script="Java" typeface="Javanese Text"/>
+        <a:font script="Lisu" typeface="Segoe UI"/>
+        <a:font script="Mymr" typeface="Myanmar Text"/>
+        <a:font script="Nkoo" typeface="Ebrima"/>
+        <a:font script="Olck" typeface="Nirmala UI"/>
+        <a:font script="Osma" typeface="Ebrima"/>
+        <a:font script="Phag" typeface="Phagspa"/>
+        <a:font script="Syrn" typeface="Estrangelo Edessa"/>
+        <a:font script="Syrj" typeface="Estrangelo Edessa"/>
+        <a:font script="Syre" typeface="Estrangelo Edessa"/>
+        <a:font script="Sora" typeface="Nirmala UI"/>
+        <a:font script="Tale" typeface="Microsoft Tai Le"/>
+        <a:font script="Talu" typeface="Microsoft New Tai Lue"/>
+        <a:font script="Tfng" typeface="Ebrima"/>
+      </a:minorFont>
+    </a:fontScheme>
+    <a:fmtScheme name="Office">
+      <a:fillStyleLst>
+        <a:solidFill>
+          <a:schemeClr val="phClr"/>
+        </a:solidFill>
+        <a:gradFill rotWithShape="1">
+          <a:gsLst>
+            <a:gs pos="0">
+              <a:schemeClr val="phClr">
+                <a:lumMod val="110000"/>
+                <a:satMod val="105000"/>
+                <a:tint val="67000"/>
+              </a:schemeClr>
+            </a:gs>
+            <a:gs pos="50000">
+              <a:schemeClr val="phClr">
+                <a:lumMod val="105000"/>
+                <a:satMod val="103000"/>
+                <a:tint val="73000"/>
+              </a:schemeClr>
+            </a:gs>
+            <a:gs pos="100000">
+              <a:schemeClr val="phClr">
+                <a:lumMod val="105000"/>
+                <a:satMod val="109000"/>
+                <a:tint val="81000"/>
+              </a:schemeClr>
+            </a:gs>
+          </a:gsLst>
+          <a:lin ang="5400000" scaled="0"/>
+        </a:gradFill>
+        <a:gradFill rotWithShape="1">
+          <a:gsLst>
+            <a:gs pos="0">
+              <a:schemeClr val="phClr">
+                <a:satMod val="103000"/>
+                <a:lumMod val="102000"/>
+                <a:tint val="94000"/>
+              </a:schemeClr>
+            </a:gs>
+            <a:gs pos="50000">
+              <a:schemeClr val="phClr">
+                <a:satMod val="110000"/>
+                <a:lumMod val="100000"/>
+                <a:shade val="100000"/>
+              </a:schemeClr>
+            </a:gs>
+            <a:gs pos="100000">
+              <a:schemeClr val="phClr">
+                <a:lumMod val="99000"/>
+                <a:satMod val="120000"/>
+                <a:shade val="78000"/>
+              </a:schemeClr>
+            </a:gs>
+          </a:gsLst>
+          <a:lin ang="5400000" scaled="0"/>
+        </a:gradFill>
+      </a:fillStyleLst>
+      <a:lnStyleLst>
+        <a:ln w="12700" cap="flat" cmpd="sng" algn="ctr">
+          <a:solidFill>
+            <a:schemeClr val="phClr"/>
+          </a:solidFill>
+          <a:prstDash val="solid"/>
+          <a:miter lim="800000"/>
+        </a:ln>
+        <a:ln w="19050" cap="flat" cmpd="sng" algn="ctr">
+          <a:solidFill>
+            <a:schemeClr val="phClr"/>
+          </a:solidFill>
+          <a:prstDash val="solid"/>
+          <a:miter lim="800000"/>
+        </a:ln>
+        <a:ln w="25400" cap="flat" cmpd="sng" algn="ctr">
+          <a:solidFill>
+            <a:schemeClr val="phClr"/>
+          </a:solidFill>
+          <a:prstDash val="solid"/>
+          <a:miter lim="800000"/>
+        </a:ln>
+      </a:lnStyleLst>
+      <a:effectStyleLst>
+        <a:effectStyle>
+          <a:effectLst/>
+        </a:effectStyle>
+        <a:effectStyle>
+          <a:effectLst/>
+        </a:effectStyle>
+        <a:effectStyle>
+          <a:effectLst>
+            <a:outerShdw blurRad="57150" dist="19050" dir="5400000" algn="ctr" rotWithShape="0">
+              <a:srgbClr val="000000">
+                <a:alpha val="63000"/>
+              </a:srgbClr>
+            </a:outerShdw>
+          </a:effectLst>
+        </a:effectStyle>
+      </a:effectStyleLst>
+      <a:bgFillStyleLst>
+        <a:solidFill>
+          <a:schemeClr val="phClr"/>
+        </a:solidFill>
+        <a:solidFill>
+          <a:schemeClr val="phClr">
+            <a:tint val="95000"/>
+            <a:satMod val="170000"/>
+          </a:schemeClr>
+        </a:solidFill>
+        <a:gradFill rotWithShape="1">
+          <a:gsLst>
+            <a:gs pos="0">
+              <a:schemeClr val="phClr">
+                <a:tint val="93000"/>
+                <a:satMod val="150000"/>
+                <a:shade val="98000"/>
+                <a:lumMod val="102000"/>
+              </a:schemeClr>
+            </a:gs>
+            <a:gs pos="50000">
+              <a:schemeClr val="phClr">
+                <a:tint val="98000"/>
+                <a:satMod val="130000"/>
+                <a:shade val="90000"/>
+                <a:lumMod val="103000"/>
+              </a:schemeClr>
+            </a:gs>
+            <a:gs pos="100000">
+              <a:schemeClr val="phClr">
+                <a:shade val="63000"/>
+                <a:satMod val="120000"/>
+              </a:schemeClr>
+            </a:gs>
+          </a:gsLst>
+          <a:lin ang="5400000" scaled="0"/>
+        </a:gradFill>
+      </a:bgFillStyleLst>
+    </a:fmtScheme>
+  </a:themeElements>
+  <a:objectDefaults>
+    <a:lnDef>
+      <a:spPr/>
+      <a:bodyPr/>
+      <a:lstStyle/>
+      <a:style>
+        <a:lnRef idx="2">
+          <a:schemeClr val="accent1"/>
+        </a:lnRef>
+        <a:fillRef idx="0">
+          <a:schemeClr val="accent1"/>
+        </a:fillRef>
+        <a:effectRef idx="1">
+          <a:schemeClr val="accent1"/>
+        </a:effectRef>
+        <a:fontRef idx="minor">
+          <a:schemeClr val="tx1"/>
+        </a:fontRef>
+      </a:style>
+    </a:lnDef>
+  </a:objectDefaults>
+  <a:extraClrSchemeLst/>
+  <a:extLst>
+    <a:ext uri="{05A4C25C-085E-4340-85A3-A5531E510DB2}">
+      <thm15:themeFamily xmlns:thm15="http://schemas.microsoft.com/office/thememl/2012/main" name="Office Theme" id="{2E142A2C-CD16-42D6-873A-C26D2A0506FA}" vid="{1BDDFF52-6CD6-40A5-AB3C-68EB2F1E4D0A}"/>
+    </a:ext>
+  </a:extLst>
+</a:theme>
 </file>
</xml_diff>